<commit_message>
Mise à jour : ajout et suppression de fichiers
</commit_message>
<xml_diff>
--- a/3-Apprentissage automatique/1-soldes Walmart/Walmart_Presentation.pptx
+++ b/3-Apprentissage automatique/1-soldes Walmart/Walmart_Presentation.pptx
@@ -6964,7 +6964,7 @@
                 <a:ea typeface="Calibri" pitchFamily="34" charset="-122"/>
                 <a:cs typeface="Calibri" pitchFamily="34" charset="-120"/>
               </a:rPr>
-              <a:t> </a:t>
+              <a:t xml:space="preserve"> </a:t>
             </a:r>
             <a:endParaRPr lang="fr-FR" sz="1200" noProof="0" dirty="0"/>
           </a:p>
@@ -6998,7 +6998,7 @@
                 <a:ea typeface="Calibri" pitchFamily="34" charset="-122"/>
                 <a:cs typeface="Calibri" pitchFamily="34" charset="-120"/>
               </a:rPr>
-              <a:t> </a:t>
+              <a:t xml:space="preserve"> </a:t>
             </a:r>
             <a:endParaRPr lang="fr-FR" sz="1200" noProof="0" dirty="0"/>
           </a:p>
@@ -7680,7 +7680,7 @@
                 <a:ea typeface="Calibri" pitchFamily="34" charset="-122"/>
                 <a:cs typeface="Calibri" pitchFamily="34" charset="-120"/>
               </a:rPr>
-              <a:t>02 - Description du jeu de </a:t>
+              <a:t xml:space="preserve">02 - Description du jeu de </a:t>
             </a:r>
             <a:r>
               <a:rPr lang="fr-FR" sz="2200" b="1" noProof="0" dirty="0" err="1">
@@ -10922,7 +10922,7 @@
                 <a:ea typeface="Calibri" pitchFamily="34" charset="-122"/>
                 <a:cs typeface="Calibri" pitchFamily="34" charset="-120"/>
               </a:rPr>
-              <a:t>Distribution asymétrique (270k$ a 2.8M$). </a:t>
+              <a:t>Distribution bimodale (270k$ à 2,8M$), médiane ~1,2M$.</a:t>
             </a:r>
           </a:p>
           <a:p>
@@ -10938,29 +10938,7 @@
                 <a:ea typeface="Calibri" pitchFamily="34" charset="-122"/>
                 <a:cs typeface="Calibri" pitchFamily="34" charset="-120"/>
               </a:rPr>
-              <a:t>Les </a:t>
-            </a:r>
-            <a:r>
-              <a:rPr lang="fr-FR" sz="1000" noProof="0" dirty="0" err="1">
-                <a:solidFill>
-                  <a:srgbClr val="374151"/>
-                </a:solidFill>
-                <a:latin typeface="Calibri" pitchFamily="34" charset="0"/>
-                <a:ea typeface="Calibri" pitchFamily="34" charset="-122"/>
-                <a:cs typeface="Calibri" pitchFamily="34" charset="-120"/>
-              </a:rPr>
-              <a:t>extremes</a:t>
-            </a:r>
-            <a:r>
-              <a:rPr lang="fr-FR" sz="1000" noProof="0" dirty="0">
-                <a:solidFill>
-                  <a:srgbClr val="374151"/>
-                </a:solidFill>
-                <a:latin typeface="Calibri" pitchFamily="34" charset="0"/>
-                <a:ea typeface="Calibri" pitchFamily="34" charset="-122"/>
-                <a:cs typeface="Calibri" pitchFamily="34" charset="-120"/>
-              </a:rPr>
-              <a:t> correspondent aux magasins les plus performants.</a:t>
+              <a:t>Deux groupes de magasins aux profils très distincts. Moustache droite allongée : hétérogénéité inter-magasins réelle.</a:t>
             </a:r>
             <a:endParaRPr lang="fr-FR" sz="1000" noProof="0" dirty="0"/>
           </a:p>
@@ -11258,7 +11236,7 @@
                 <a:ea typeface="Calibri" pitchFamily="34" charset="-122"/>
                 <a:cs typeface="Calibri" pitchFamily="34" charset="-120"/>
               </a:rPr>
-              <a:t>Certains magasins génèrent 3x plus de ventes. </a:t>
+              <a:t xml:space="preserve">Certains magasins génèrent 3x plus de ventes. </a:t>
             </a:r>
           </a:p>
           <a:p>
@@ -11721,7 +11699,7 @@
                 <a:ea typeface="Calibri" pitchFamily="34" charset="-122"/>
                 <a:cs typeface="Calibri" pitchFamily="34" charset="-120"/>
               </a:rPr>
-              <a:t>CPI (|r|=0.287) et Température (|r|=0.166) sont les plus corrélées. </a:t>
+              <a:t xml:space="preserve">CPI (|r|=0.287) et Température (|r|=0.166) sont les plus corrélées. </a:t>
             </a:r>
           </a:p>
           <a:p>
@@ -11841,7 +11819,7 @@
                 <a:ea typeface="Calibri" pitchFamily="34" charset="-122"/>
                 <a:cs typeface="Calibri" pitchFamily="34" charset="-120"/>
               </a:rPr>
-              <a:t>04 - </a:t>
+              <a:t xml:space="preserve">04 - </a:t>
             </a:r>
             <a:r>
               <a:rPr lang="fr-FR" sz="2200" b="1" noProof="0" dirty="0" err="1">
@@ -11863,7 +11841,7 @@
                 <a:ea typeface="Calibri" pitchFamily="34" charset="-122"/>
                 <a:cs typeface="Calibri" pitchFamily="34" charset="-120"/>
               </a:rPr>
-              <a:t> des </a:t>
+              <a:t xml:space="preserve"> des </a:t>
             </a:r>
             <a:r>
               <a:rPr lang="fr-FR" sz="2200" b="1" noProof="0" dirty="0" err="1">
@@ -12596,7 +12574,7 @@
                 <a:ea typeface="Calibri" pitchFamily="34" charset="-122"/>
                 <a:cs typeface="Calibri" pitchFamily="34" charset="-120"/>
               </a:rPr>
-              <a:t> (2 valeurs - 1 = 1 col)</a:t>
+              <a:t xml:space="preserve"> (2 valeurs - 1 = 1 col)</a:t>
             </a:r>
             <a:endParaRPr lang="fr-FR" sz="1100" noProof="0" dirty="0"/>
           </a:p>
@@ -12861,7 +12839,7 @@
                 <a:ea typeface="Calibri" pitchFamily="34" charset="-122"/>
                 <a:cs typeface="Calibri" pitchFamily="34" charset="-120"/>
               </a:rPr>
-              <a:t> final</a:t>
+              <a:t xml:space="preserve"> final</a:t>
             </a:r>
             <a:endParaRPr lang="fr-FR" sz="900" noProof="0" dirty="0"/>
           </a:p>
@@ -12911,7 +12889,7 @@
                 <a:ea typeface="Calibri" pitchFamily="34" charset="-122"/>
                 <a:cs typeface="Calibri" pitchFamily="34" charset="-120"/>
               </a:rPr>
-              <a:t> : (56, 26)  |  </a:t>
+              <a:t xml:space="preserve"> : (56, 26)  |  </a:t>
             </a:r>
             <a:r>
               <a:rPr lang="fr-FR" sz="1100" noProof="0" dirty="0" err="1">
@@ -12933,7 +12911,7 @@
                 <a:ea typeface="Calibri" pitchFamily="34" charset="-122"/>
                 <a:cs typeface="Calibri" pitchFamily="34" charset="-120"/>
               </a:rPr>
-              <a:t> : (15, 26)</a:t>
+              <a:t xml:space="preserve"> : (15, 26)</a:t>
             </a:r>
             <a:endParaRPr lang="fr-FR" sz="1100" noProof="0" dirty="0"/>
           </a:p>
@@ -13831,7 +13809,7 @@
                 <a:ea typeface="Calibri" pitchFamily="34" charset="-122"/>
                 <a:cs typeface="Calibri" pitchFamily="34" charset="-120"/>
               </a:rPr>
-              <a:t>Top variables - impact sur </a:t>
+              <a:t xml:space="preserve">Top variables - impact sur </a:t>
             </a:r>
             <a:r>
               <a:rPr lang="fr-FR" sz="1200" b="1" noProof="0" dirty="0" err="1">
@@ -14685,7 +14663,7 @@
                 <a:ea typeface="Calibri" pitchFamily="34" charset="-122"/>
                 <a:cs typeface="Calibri" pitchFamily="34" charset="-120"/>
               </a:rPr>
-              <a:t> </a:t>
+              <a:t xml:space="preserve"> </a:t>
             </a:r>
             <a:endParaRPr lang="fr-FR" sz="1100" noProof="0" dirty="0"/>
           </a:p>
@@ -14896,7 +14874,7 @@
                 <a:ea typeface="Calibri" pitchFamily="34" charset="-122"/>
                 <a:cs typeface="Calibri" pitchFamily="34" charset="-120"/>
               </a:rPr>
-              <a:t>La régularisation pénalise les grands coefficients pour réduire l'overfitting. </a:t>
+              <a:t xml:space="preserve">La régularisation pénalise les grands coefficients pour réduire l'overfitting. </a:t>
             </a:r>
           </a:p>
           <a:p>
@@ -14912,7 +14890,7 @@
                 <a:ea typeface="Calibri" pitchFamily="34" charset="-122"/>
                 <a:cs typeface="Calibri" pitchFamily="34" charset="-120"/>
               </a:rPr>
-              <a:t>L'hyperparamètre alpha contrôle la force de la pénalité : plus alpha est grand, plus les </a:t>
+              <a:t xml:space="preserve">L'hyperparamètre alpha contrôle la force de la pénalité : plus alpha est grand, plus les </a:t>
             </a:r>
             <a:r>
               <a:rPr lang="fr-FR" sz="1100" i="1" noProof="0" dirty="0" err="1">
@@ -14934,7 +14912,7 @@
                 <a:ea typeface="Calibri" pitchFamily="34" charset="-122"/>
                 <a:cs typeface="Calibri" pitchFamily="34" charset="-120"/>
               </a:rPr>
-              <a:t> sont contraints.</a:t>
+              <a:t xml:space="preserve"> sont contraints.</a:t>
             </a:r>
             <a:endParaRPr lang="fr-FR" sz="1100" noProof="0" dirty="0"/>
           </a:p>
@@ -15117,7 +15095,7 @@
                 <a:ea typeface="Calibri" pitchFamily="34" charset="-122"/>
                 <a:cs typeface="Calibri" pitchFamily="34" charset="-120"/>
               </a:rPr>
-              <a:t> </a:t>
+              <a:t xml:space="preserve"> </a:t>
             </a:r>
             <a:endParaRPr lang="fr-FR" sz="1100" noProof="0" dirty="0"/>
           </a:p>
@@ -15168,7 +15146,7 @@
                 <a:ea typeface="Calibri" pitchFamily="34" charset="-122"/>
                 <a:cs typeface="Calibri" pitchFamily="34" charset="-120"/>
               </a:rPr>
-              <a:t> </a:t>
+              <a:t xml:space="preserve"> </a:t>
             </a:r>
             <a:endParaRPr lang="fr-FR" sz="1100" noProof="0" dirty="0"/>
           </a:p>
@@ -15419,7 +15397,7 @@
                 <a:ea typeface="Calibri" pitchFamily="34" charset="-122"/>
                 <a:cs typeface="Calibri" pitchFamily="34" charset="-120"/>
               </a:rPr>
-              <a:t> </a:t>
+              <a:t xml:space="preserve"> </a:t>
             </a:r>
             <a:endParaRPr lang="fr-FR" sz="1100" noProof="0" dirty="0"/>
           </a:p>
@@ -15453,7 +15431,7 @@
                 <a:ea typeface="Calibri" pitchFamily="34" charset="-122"/>
                 <a:cs typeface="Calibri" pitchFamily="34" charset="-120"/>
               </a:rPr>
-              <a:t>Meilleur alpha = 1000. Le R² augmente continuellement : la sélection de variables améliore la généralisation.</a:t>
+              <a:t>Meilleur alpha = 1000. Le R² augmente jusqu’au bord de la grille : élargir la recherche (5 000, 10 000) pour confirmer l’optimum global.</a:t>
             </a:r>
             <a:endParaRPr lang="fr-FR" sz="1100" noProof="0" dirty="0"/>
           </a:p>
@@ -15470,7 +15448,7 @@
                 <a:ea typeface="Calibri" pitchFamily="34" charset="-122"/>
                 <a:cs typeface="Calibri" pitchFamily="34" charset="-120"/>
               </a:rPr>
-              <a:t> </a:t>
+              <a:t xml:space="preserve"> </a:t>
             </a:r>
             <a:endParaRPr lang="fr-FR" sz="1100" noProof="0" dirty="0"/>
           </a:p>

</xml_diff>